<commit_message>
coverage over time figures + pptx updated
</commit_message>
<xml_diff>
--- a/docs_llm/FormatFuzzer Tiered Strategy.pptx
+++ b/docs_llm/FormatFuzzer Tiered Strategy.pptx
@@ -26742,7 +26742,7 @@
                 <a:ea typeface="Calibri" pitchFamily="34" charset="-122"/>
                 <a:cs typeface="Calibri" pitchFamily="34" charset="-120"/>
               </a:rPr>
-              <a:t>gif2rgb without -1 writes three colour planes by appending .R/.G/.B to the output name, so "/dev/null.R" could not be created — exit 253 for valid and invalid input alike.</a:t>
+              <a:t>gif2rgb without -1 writes three colour planes by appending .R/.G/.B to the output name, so "/dev/null.R" could not be created — exit 253 for valid and invalid input alike. All three variants rose, by +2.4, +4.6 and +2.9.</a:t>
             </a:r>
             <a:endParaRPr lang="en-US" sz="1150" dirty="0"/>
           </a:p>
@@ -26805,13 +26805,13 @@
             <a:r>
               <a:rPr lang="en-US" sz="1050" dirty="0">
                 <a:solidFill>
-                  <a:srgbClr val="16202B"/>
+                  <a:srgbClr val="C0492F"/>
                 </a:solidFill>
                 <a:latin typeface="Courier New" pitchFamily="34" charset="0"/>
                 <a:ea typeface="Courier New" pitchFamily="34" charset="-122"/>
                 <a:cs typeface="Courier New" pitchFamily="34" charset="-120"/>
               </a:rPr>
-              <a:t>cost   ~2.5 points, uniformly across all three variants</a:t>
+              <a:t>before  26.8 / 24.6 / 26.3 %   &lt;- aborted before the RGB dump</a:t>
             </a:r>
             <a:endParaRPr lang="en-US" sz="1050" dirty="0"/>
           </a:p>
@@ -26825,13 +26825,13 @@
             <a:r>
               <a:rPr lang="en-US" sz="1050" dirty="0">
                 <a:solidFill>
-                  <a:srgbClr val="16202B"/>
+                  <a:srgbClr val="2E8B62"/>
                 </a:solidFill>
                 <a:latin typeface="Courier New" pitchFamily="34" charset="0"/>
                 <a:ea typeface="Courier New" pitchFamily="34" charset="-122"/>
                 <a:cs typeface="Courier New" pitchFamily="34" charset="-120"/>
               </a:rPr>
-              <a:t>       ranking unchanged — absolute values only</a:t>
+              <a:t>after   29.2 / 29.2 / 29.2 %   &lt;- and the three then tie</a:t>
             </a:r>
             <a:endParaRPr lang="en-US" sz="1050" dirty="0"/>
           </a:p>

</xml_diff>